<commit_message>
Clientes Marília: Isa Silveira diretora e Leo Torres líder de criação
Co-Authored-By: Claude Opus 5.5 <noreply@anthropic.com>
Claude-Session: https://claude.ai/code/session_014GpjQY6RnNWB41ppyTzDeJ
</commit_message>
<xml_diff>
--- a/Organogramas_Clientes_Marilia.pptx
+++ b/Organogramas_Clientes_Marilia.pptx
@@ -1811,7 +1811,7 @@
                 <a:ea typeface="Arial" pitchFamily="34" charset="-122"/>
                 <a:cs typeface="Arial" pitchFamily="34" charset="-120"/>
               </a:rPr>
-              <a:t>ISA SILVEIRA + LEO TORRES</a:t>
+              <a:t>ISA SILVEIRA</a:t>
             </a:r>
             <a:endParaRPr lang="pt-BR" sz="1200" dirty="0"/>
           </a:p>
@@ -1831,7 +1831,7 @@
                 <a:ea typeface="Arial" pitchFamily="34" charset="-122"/>
                 <a:cs typeface="Arial" pitchFamily="34" charset="-120"/>
               </a:rPr>
-              <a:t>Liderança de criação</a:t>
+              <a:t>Diretora de criação</a:t>
             </a:r>
             <a:endParaRPr lang="pt-BR" sz="1200" dirty="0"/>
           </a:p>
@@ -1845,7 +1845,117 @@
         </p:nvSpPr>
         <p:spPr>
           <a:xfrm>
-            <a:off x="4436532" y="3721608"/>
+            <a:off x="6095998" y="3658108"/>
+            <a:ext cx="0" cy="152400"/>
+          </a:xfrm>
+          <a:prstGeom prst="line">
+            <a:avLst/>
+          </a:prstGeom>
+          <a:noFill/>
+          <a:ln w="19050">
+            <a:solidFill>
+              <a:srgbClr val="141414"/>
+            </a:solidFill>
+            <a:prstDash val="solid"/>
+          </a:ln>
+        </p:spPr>
+      </p:sp>
+      <p:sp>
+        <p:nvSpPr>
+          <p:cNvPr id="29" name="Shape 29"/>
+          <p:cNvSpPr/>
+          <p:nvPr/>
+        </p:nvSpPr>
+        <p:spPr>
+          <a:xfrm>
+            <a:off x="4436532" y="3810508"/>
+            <a:ext cx="3318933" cy="521208"/>
+          </a:xfrm>
+          <a:prstGeom prst="rect">
+            <a:avLst/>
+          </a:prstGeom>
+          <a:solidFill>
+            <a:srgbClr val="FFFFFF"/>
+          </a:solidFill>
+          <a:ln w="19050">
+            <a:solidFill>
+              <a:srgbClr val="EC6A3B"/>
+            </a:solidFill>
+            <a:prstDash val="solid"/>
+          </a:ln>
+        </p:spPr>
+      </p:sp>
+      <p:sp>
+        <p:nvSpPr>
+          <p:cNvPr id="30" name="Text 30"/>
+          <p:cNvSpPr txBox="1"/>
+          <p:nvPr/>
+        </p:nvSpPr>
+        <p:spPr>
+          <a:xfrm>
+            <a:off x="4436532" y="3810508"/>
+            <a:ext cx="3318933" cy="521208"/>
+          </a:xfrm>
+          <a:prstGeom prst="rect">
+            <a:avLst/>
+          </a:prstGeom>
+          <a:noFill/>
+          <a:ln/>
+        </p:spPr>
+        <p:txBody>
+          <a:bodyPr wrap="square" lIns="50800" tIns="76200" rIns="101600" bIns="50800" rtlCol="0" anchor="ctr"/>
+          <a:lstStyle/>
+          <a:p>
+            <a:pPr algn="ctr" indent="0" marL="0">
+              <a:spcAft>
+                <a:spcPts val="200"/>
+              </a:spcAft>
+              <a:buNone/>
+            </a:pPr>
+            <a:r>
+              <a:rPr lang="pt-BR" sz="1200" b="1" dirty="0">
+                <a:solidFill>
+                  <a:srgbClr val="141414"/>
+                </a:solidFill>
+                <a:latin typeface="Arial" pitchFamily="34" charset="0"/>
+                <a:ea typeface="Arial" pitchFamily="34" charset="-122"/>
+                <a:cs typeface="Arial" pitchFamily="34" charset="-120"/>
+              </a:rPr>
+              <a:t>LEO TORRES</a:t>
+            </a:r>
+            <a:endParaRPr lang="pt-BR" sz="1200" dirty="0"/>
+          </a:p>
+          <a:p>
+            <a:pPr algn="ctr" indent="0" marL="0">
+              <a:spcAft>
+                <a:spcPts val="200"/>
+              </a:spcAft>
+              <a:buNone/>
+            </a:pPr>
+            <a:r>
+              <a:rPr lang="pt-BR" sz="1200" dirty="0">
+                <a:solidFill>
+                  <a:srgbClr val="5E5E5E"/>
+                </a:solidFill>
+                <a:latin typeface="Arial" pitchFamily="34" charset="0"/>
+                <a:ea typeface="Arial" pitchFamily="34" charset="-122"/>
+                <a:cs typeface="Arial" pitchFamily="34" charset="-120"/>
+              </a:rPr>
+              <a:t>Líder de criação</a:t>
+            </a:r>
+            <a:endParaRPr lang="pt-BR" sz="1200" dirty="0"/>
+          </a:p>
+        </p:txBody>
+      </p:sp>
+      <p:sp>
+        <p:nvSpPr>
+          <p:cNvPr id="31" name="Shape 31"/>
+          <p:cNvSpPr/>
+          <p:nvPr/>
+        </p:nvSpPr>
+        <p:spPr>
+          <a:xfrm>
+            <a:off x="4436532" y="4395216"/>
             <a:ext cx="1621366" cy="521208"/>
           </a:xfrm>
           <a:prstGeom prst="rect">
@@ -1864,13 +1974,13 @@
       </p:sp>
       <p:sp>
         <p:nvSpPr>
-          <p:cNvPr id="29" name="Text 29"/>
-          <p:cNvSpPr txBox="1"/>
-          <p:nvPr/>
-        </p:nvSpPr>
-        <p:spPr>
-          <a:xfrm>
-            <a:off x="4436532" y="3721608"/>
+          <p:cNvPr id="32" name="Text 32"/>
+          <p:cNvSpPr txBox="1"/>
+          <p:nvPr/>
+        </p:nvSpPr>
+        <p:spPr>
+          <a:xfrm>
+            <a:off x="4436532" y="4395216"/>
             <a:ext cx="1621366" cy="521208"/>
           </a:xfrm>
           <a:prstGeom prst="rect">
@@ -1926,13 +2036,13 @@
       </p:sp>
       <p:sp>
         <p:nvSpPr>
-          <p:cNvPr id="30" name="Shape 30"/>
-          <p:cNvSpPr/>
-          <p:nvPr/>
-        </p:nvSpPr>
-        <p:spPr>
-          <a:xfrm>
-            <a:off x="6134098" y="3721608"/>
+          <p:cNvPr id="33" name="Shape 33"/>
+          <p:cNvSpPr/>
+          <p:nvPr/>
+        </p:nvSpPr>
+        <p:spPr>
+          <a:xfrm>
+            <a:off x="6134098" y="4395216"/>
             <a:ext cx="1621366" cy="521208"/>
           </a:xfrm>
           <a:prstGeom prst="rect">
@@ -1951,13 +2061,13 @@
       </p:sp>
       <p:sp>
         <p:nvSpPr>
-          <p:cNvPr id="31" name="Text 31"/>
-          <p:cNvSpPr txBox="1"/>
-          <p:nvPr/>
-        </p:nvSpPr>
-        <p:spPr>
-          <a:xfrm>
-            <a:off x="6134098" y="3721608"/>
+          <p:cNvPr id="34" name="Text 34"/>
+          <p:cNvSpPr txBox="1"/>
+          <p:nvPr/>
+        </p:nvSpPr>
+        <p:spPr>
+          <a:xfrm>
+            <a:off x="6134098" y="4395216"/>
             <a:ext cx="1621366" cy="521208"/>
           </a:xfrm>
           <a:prstGeom prst="rect">
@@ -2013,13 +2123,13 @@
       </p:sp>
       <p:sp>
         <p:nvSpPr>
-          <p:cNvPr id="32" name="Shape 32"/>
-          <p:cNvSpPr/>
-          <p:nvPr/>
-        </p:nvSpPr>
-        <p:spPr>
-          <a:xfrm>
-            <a:off x="4436532" y="4306316"/>
+          <p:cNvPr id="35" name="Shape 35"/>
+          <p:cNvSpPr/>
+          <p:nvPr/>
+        </p:nvSpPr>
+        <p:spPr>
+          <a:xfrm>
+            <a:off x="4436532" y="4979924"/>
             <a:ext cx="1621366" cy="521208"/>
           </a:xfrm>
           <a:prstGeom prst="rect">
@@ -2038,13 +2148,13 @@
       </p:sp>
       <p:sp>
         <p:nvSpPr>
-          <p:cNvPr id="33" name="Text 33"/>
-          <p:cNvSpPr txBox="1"/>
-          <p:nvPr/>
-        </p:nvSpPr>
-        <p:spPr>
-          <a:xfrm>
-            <a:off x="4436532" y="4306316"/>
+          <p:cNvPr id="36" name="Text 36"/>
+          <p:cNvSpPr txBox="1"/>
+          <p:nvPr/>
+        </p:nvSpPr>
+        <p:spPr>
+          <a:xfrm>
+            <a:off x="4436532" y="4979924"/>
             <a:ext cx="1621366" cy="521208"/>
           </a:xfrm>
           <a:prstGeom prst="rect">
@@ -2100,13 +2210,13 @@
       </p:sp>
       <p:sp>
         <p:nvSpPr>
-          <p:cNvPr id="34" name="Shape 34"/>
-          <p:cNvSpPr/>
-          <p:nvPr/>
-        </p:nvSpPr>
-        <p:spPr>
-          <a:xfrm>
-            <a:off x="6134098" y="4306316"/>
+          <p:cNvPr id="37" name="Shape 37"/>
+          <p:cNvSpPr/>
+          <p:nvPr/>
+        </p:nvSpPr>
+        <p:spPr>
+          <a:xfrm>
+            <a:off x="6134098" y="4979924"/>
             <a:ext cx="1621366" cy="521208"/>
           </a:xfrm>
           <a:prstGeom prst="rect">
@@ -2125,13 +2235,13 @@
       </p:sp>
       <p:sp>
         <p:nvSpPr>
-          <p:cNvPr id="35" name="Text 35"/>
-          <p:cNvSpPr txBox="1"/>
-          <p:nvPr/>
-        </p:nvSpPr>
-        <p:spPr>
-          <a:xfrm>
-            <a:off x="6134098" y="4306316"/>
+          <p:cNvPr id="38" name="Text 38"/>
+          <p:cNvSpPr txBox="1"/>
+          <p:nvPr/>
+        </p:nvSpPr>
+        <p:spPr>
+          <a:xfrm>
+            <a:off x="6134098" y="4979924"/>
             <a:ext cx="1621366" cy="521208"/>
           </a:xfrm>
           <a:prstGeom prst="rect">
@@ -2187,7 +2297,7 @@
       </p:sp>
       <p:sp>
         <p:nvSpPr>
-          <p:cNvPr id="36" name="Text 36"/>
+          <p:cNvPr id="39" name="Text 39"/>
           <p:cNvSpPr txBox="1"/>
           <p:nvPr/>
         </p:nvSpPr>
@@ -2228,7 +2338,7 @@
       </p:sp>
       <p:sp>
         <p:nvSpPr>
-          <p:cNvPr id="37" name="Shape 37"/>
+          <p:cNvPr id="40" name="Shape 40"/>
           <p:cNvSpPr/>
           <p:nvPr/>
         </p:nvSpPr>
@@ -2253,7 +2363,7 @@
       </p:sp>
       <p:sp>
         <p:nvSpPr>
-          <p:cNvPr id="38" name="Text 38"/>
+          <p:cNvPr id="41" name="Text 41"/>
           <p:cNvSpPr txBox="1"/>
           <p:nvPr/>
         </p:nvSpPr>
@@ -2315,7 +2425,7 @@
       </p:sp>
       <p:sp>
         <p:nvSpPr>
-          <p:cNvPr id="39" name="Shape 39"/>
+          <p:cNvPr id="42" name="Shape 42"/>
           <p:cNvSpPr/>
           <p:nvPr/>
         </p:nvSpPr>
@@ -2340,7 +2450,7 @@
       </p:sp>
       <p:sp>
         <p:nvSpPr>
-          <p:cNvPr id="40" name="Text 40"/>
+          <p:cNvPr id="43" name="Text 43"/>
           <p:cNvSpPr txBox="1"/>
           <p:nvPr/>
         </p:nvSpPr>
@@ -2402,7 +2512,7 @@
       </p:sp>
       <p:sp>
         <p:nvSpPr>
-          <p:cNvPr id="41" name="Text 41"/>
+          <p:cNvPr id="44" name="Text 44"/>
           <p:cNvSpPr txBox="1"/>
           <p:nvPr/>
         </p:nvSpPr>
@@ -2443,7 +2553,7 @@
       </p:sp>
       <p:sp>
         <p:nvSpPr>
-          <p:cNvPr id="42" name="Shape 42"/>
+          <p:cNvPr id="45" name="Shape 45"/>
           <p:cNvSpPr/>
           <p:nvPr/>
         </p:nvSpPr>
@@ -2468,7 +2578,7 @@
       </p:sp>
       <p:sp>
         <p:nvSpPr>
-          <p:cNvPr id="43" name="Text 43"/>
+          <p:cNvPr id="46" name="Text 46"/>
           <p:cNvSpPr txBox="1"/>
           <p:nvPr/>
         </p:nvSpPr>
@@ -2530,7 +2640,7 @@
       </p:sp>
       <p:sp>
         <p:nvSpPr>
-          <p:cNvPr id="44" name="Text 44"/>
+          <p:cNvPr id="47" name="Text 47"/>
           <p:cNvSpPr txBox="1"/>
           <p:nvPr/>
         </p:nvSpPr>
@@ -2569,7 +2679,7 @@
       </p:sp>
       <p:sp>
         <p:nvSpPr>
-          <p:cNvPr id="45" name="Shape 45"/>
+          <p:cNvPr id="48" name="Shape 48"/>
           <p:cNvSpPr/>
           <p:nvPr/>
         </p:nvSpPr>
@@ -2594,7 +2704,7 @@
       </p:sp>
       <p:sp>
         <p:nvSpPr>
-          <p:cNvPr id="46" name="Text 46"/>
+          <p:cNvPr id="49" name="Text 49"/>
           <p:cNvSpPr txBox="1"/>
           <p:nvPr/>
         </p:nvSpPr>
@@ -2633,7 +2743,7 @@
       </p:sp>
       <p:sp>
         <p:nvSpPr>
-          <p:cNvPr id="47" name="Shape 47"/>
+          <p:cNvPr id="50" name="Shape 50"/>
           <p:cNvSpPr/>
           <p:nvPr/>
         </p:nvSpPr>
@@ -3514,7 +3624,7 @@
                 <a:ea typeface="Arial" pitchFamily="34" charset="-122"/>
                 <a:cs typeface="Arial" pitchFamily="34" charset="-120"/>
               </a:rPr>
-              <a:t>ISA SILVEIRA + LEO TORRES</a:t>
+              <a:t>ISA SILVEIRA</a:t>
             </a:r>
             <a:endParaRPr lang="pt-BR" sz="1200" dirty="0"/>
           </a:p>
@@ -3534,7 +3644,7 @@
                 <a:ea typeface="Arial" pitchFamily="34" charset="-122"/>
                 <a:cs typeface="Arial" pitchFamily="34" charset="-120"/>
               </a:rPr>
-              <a:t>Liderança de criação</a:t>
+              <a:t>Diretora de criação</a:t>
             </a:r>
             <a:endParaRPr lang="pt-BR" sz="1200" dirty="0"/>
           </a:p>
@@ -3548,7 +3658,117 @@
         </p:nvSpPr>
         <p:spPr>
           <a:xfrm>
-            <a:off x="5161280" y="3721608"/>
+            <a:off x="7183120" y="3658108"/>
+            <a:ext cx="0" cy="152400"/>
+          </a:xfrm>
+          <a:prstGeom prst="line">
+            <a:avLst/>
+          </a:prstGeom>
+          <a:noFill/>
+          <a:ln w="19050">
+            <a:solidFill>
+              <a:srgbClr val="141414"/>
+            </a:solidFill>
+            <a:prstDash val="solid"/>
+          </a:ln>
+        </p:spPr>
+      </p:sp>
+      <p:sp>
+        <p:nvSpPr>
+          <p:cNvPr id="26" name="Shape 26"/>
+          <p:cNvSpPr/>
+          <p:nvPr/>
+        </p:nvSpPr>
+        <p:spPr>
+          <a:xfrm>
+            <a:off x="5161280" y="3810508"/>
+            <a:ext cx="4043680" cy="521208"/>
+          </a:xfrm>
+          <a:prstGeom prst="rect">
+            <a:avLst/>
+          </a:prstGeom>
+          <a:solidFill>
+            <a:srgbClr val="FFFFFF"/>
+          </a:solidFill>
+          <a:ln w="19050">
+            <a:solidFill>
+              <a:srgbClr val="EC6A3B"/>
+            </a:solidFill>
+            <a:prstDash val="solid"/>
+          </a:ln>
+        </p:spPr>
+      </p:sp>
+      <p:sp>
+        <p:nvSpPr>
+          <p:cNvPr id="27" name="Text 27"/>
+          <p:cNvSpPr txBox="1"/>
+          <p:nvPr/>
+        </p:nvSpPr>
+        <p:spPr>
+          <a:xfrm>
+            <a:off x="5161280" y="3810508"/>
+            <a:ext cx="4043680" cy="521208"/>
+          </a:xfrm>
+          <a:prstGeom prst="rect">
+            <a:avLst/>
+          </a:prstGeom>
+          <a:noFill/>
+          <a:ln/>
+        </p:spPr>
+        <p:txBody>
+          <a:bodyPr wrap="square" lIns="50800" tIns="76200" rIns="101600" bIns="50800" rtlCol="0" anchor="ctr"/>
+          <a:lstStyle/>
+          <a:p>
+            <a:pPr algn="ctr" indent="0" marL="0">
+              <a:spcAft>
+                <a:spcPts val="200"/>
+              </a:spcAft>
+              <a:buNone/>
+            </a:pPr>
+            <a:r>
+              <a:rPr lang="pt-BR" sz="1200" b="1" dirty="0">
+                <a:solidFill>
+                  <a:srgbClr val="141414"/>
+                </a:solidFill>
+                <a:latin typeface="Arial" pitchFamily="34" charset="0"/>
+                <a:ea typeface="Arial" pitchFamily="34" charset="-122"/>
+                <a:cs typeface="Arial" pitchFamily="34" charset="-120"/>
+              </a:rPr>
+              <a:t>LEO TORRES</a:t>
+            </a:r>
+            <a:endParaRPr lang="pt-BR" sz="1200" dirty="0"/>
+          </a:p>
+          <a:p>
+            <a:pPr algn="ctr" indent="0" marL="0">
+              <a:spcAft>
+                <a:spcPts val="200"/>
+              </a:spcAft>
+              <a:buNone/>
+            </a:pPr>
+            <a:r>
+              <a:rPr lang="pt-BR" sz="1200" dirty="0">
+                <a:solidFill>
+                  <a:srgbClr val="5E5E5E"/>
+                </a:solidFill>
+                <a:latin typeface="Arial" pitchFamily="34" charset="0"/>
+                <a:ea typeface="Arial" pitchFamily="34" charset="-122"/>
+                <a:cs typeface="Arial" pitchFamily="34" charset="-120"/>
+              </a:rPr>
+              <a:t>Líder de criação</a:t>
+            </a:r>
+            <a:endParaRPr lang="pt-BR" sz="1200" dirty="0"/>
+          </a:p>
+        </p:txBody>
+      </p:sp>
+      <p:sp>
+        <p:nvSpPr>
+          <p:cNvPr id="28" name="Shape 28"/>
+          <p:cNvSpPr/>
+          <p:nvPr/>
+        </p:nvSpPr>
+        <p:spPr>
+          <a:xfrm>
+            <a:off x="5161280" y="4395216"/>
             <a:ext cx="1983740" cy="521208"/>
           </a:xfrm>
           <a:prstGeom prst="rect">
@@ -3567,13 +3787,13 @@
       </p:sp>
       <p:sp>
         <p:nvSpPr>
-          <p:cNvPr id="26" name="Text 26"/>
-          <p:cNvSpPr txBox="1"/>
-          <p:nvPr/>
-        </p:nvSpPr>
-        <p:spPr>
-          <a:xfrm>
-            <a:off x="5161280" y="3721608"/>
+          <p:cNvPr id="29" name="Text 29"/>
+          <p:cNvSpPr txBox="1"/>
+          <p:nvPr/>
+        </p:nvSpPr>
+        <p:spPr>
+          <a:xfrm>
+            <a:off x="5161280" y="4395216"/>
             <a:ext cx="1983740" cy="521208"/>
           </a:xfrm>
           <a:prstGeom prst="rect">
@@ -3629,13 +3849,13 @@
       </p:sp>
       <p:sp>
         <p:nvSpPr>
-          <p:cNvPr id="27" name="Shape 27"/>
-          <p:cNvSpPr/>
-          <p:nvPr/>
-        </p:nvSpPr>
-        <p:spPr>
-          <a:xfrm>
-            <a:off x="7221220" y="3721608"/>
+          <p:cNvPr id="30" name="Shape 30"/>
+          <p:cNvSpPr/>
+          <p:nvPr/>
+        </p:nvSpPr>
+        <p:spPr>
+          <a:xfrm>
+            <a:off x="7221220" y="4395216"/>
             <a:ext cx="1983740" cy="521208"/>
           </a:xfrm>
           <a:prstGeom prst="rect">
@@ -3654,13 +3874,13 @@
       </p:sp>
       <p:sp>
         <p:nvSpPr>
-          <p:cNvPr id="28" name="Text 28"/>
-          <p:cNvSpPr txBox="1"/>
-          <p:nvPr/>
-        </p:nvSpPr>
-        <p:spPr>
-          <a:xfrm>
-            <a:off x="7221220" y="3721608"/>
+          <p:cNvPr id="31" name="Text 31"/>
+          <p:cNvSpPr txBox="1"/>
+          <p:nvPr/>
+        </p:nvSpPr>
+        <p:spPr>
+          <a:xfrm>
+            <a:off x="7221220" y="4395216"/>
             <a:ext cx="1983740" cy="521208"/>
           </a:xfrm>
           <a:prstGeom prst="rect">
@@ -3716,13 +3936,13 @@
       </p:sp>
       <p:sp>
         <p:nvSpPr>
-          <p:cNvPr id="29" name="Shape 29"/>
-          <p:cNvSpPr/>
-          <p:nvPr/>
-        </p:nvSpPr>
-        <p:spPr>
-          <a:xfrm>
-            <a:off x="5161280" y="4306316"/>
+          <p:cNvPr id="32" name="Shape 32"/>
+          <p:cNvSpPr/>
+          <p:nvPr/>
+        </p:nvSpPr>
+        <p:spPr>
+          <a:xfrm>
+            <a:off x="5161280" y="4979924"/>
             <a:ext cx="1983740" cy="521208"/>
           </a:xfrm>
           <a:prstGeom prst="rect">
@@ -3741,13 +3961,13 @@
       </p:sp>
       <p:sp>
         <p:nvSpPr>
-          <p:cNvPr id="30" name="Text 30"/>
-          <p:cNvSpPr txBox="1"/>
-          <p:nvPr/>
-        </p:nvSpPr>
-        <p:spPr>
-          <a:xfrm>
-            <a:off x="5161280" y="4306316"/>
+          <p:cNvPr id="33" name="Text 33"/>
+          <p:cNvSpPr txBox="1"/>
+          <p:nvPr/>
+        </p:nvSpPr>
+        <p:spPr>
+          <a:xfrm>
+            <a:off x="5161280" y="4979924"/>
             <a:ext cx="1983740" cy="521208"/>
           </a:xfrm>
           <a:prstGeom prst="rect">
@@ -3803,13 +4023,13 @@
       </p:sp>
       <p:sp>
         <p:nvSpPr>
-          <p:cNvPr id="31" name="Shape 31"/>
-          <p:cNvSpPr/>
-          <p:nvPr/>
-        </p:nvSpPr>
-        <p:spPr>
-          <a:xfrm>
-            <a:off x="7221220" y="4306316"/>
+          <p:cNvPr id="34" name="Shape 34"/>
+          <p:cNvSpPr/>
+          <p:nvPr/>
+        </p:nvSpPr>
+        <p:spPr>
+          <a:xfrm>
+            <a:off x="7221220" y="4979924"/>
             <a:ext cx="1983740" cy="521208"/>
           </a:xfrm>
           <a:prstGeom prst="rect">
@@ -3828,13 +4048,13 @@
       </p:sp>
       <p:sp>
         <p:nvSpPr>
-          <p:cNvPr id="32" name="Text 32"/>
-          <p:cNvSpPr txBox="1"/>
-          <p:nvPr/>
-        </p:nvSpPr>
-        <p:spPr>
-          <a:xfrm>
-            <a:off x="7221220" y="4306316"/>
+          <p:cNvPr id="35" name="Text 35"/>
+          <p:cNvSpPr txBox="1"/>
+          <p:nvPr/>
+        </p:nvSpPr>
+        <p:spPr>
+          <a:xfrm>
+            <a:off x="7221220" y="4979924"/>
             <a:ext cx="1983740" cy="521208"/>
           </a:xfrm>
           <a:prstGeom prst="rect">
@@ -3890,7 +4110,7 @@
       </p:sp>
       <p:sp>
         <p:nvSpPr>
-          <p:cNvPr id="33" name="Text 33"/>
+          <p:cNvPr id="36" name="Text 36"/>
           <p:cNvSpPr txBox="1"/>
           <p:nvPr/>
         </p:nvSpPr>
@@ -3931,7 +4151,7 @@
       </p:sp>
       <p:sp>
         <p:nvSpPr>
-          <p:cNvPr id="34" name="Shape 34"/>
+          <p:cNvPr id="37" name="Shape 37"/>
           <p:cNvSpPr/>
           <p:nvPr/>
         </p:nvSpPr>
@@ -3956,7 +4176,7 @@
       </p:sp>
       <p:sp>
         <p:nvSpPr>
-          <p:cNvPr id="35" name="Text 35"/>
+          <p:cNvPr id="38" name="Text 38"/>
           <p:cNvSpPr txBox="1"/>
           <p:nvPr/>
         </p:nvSpPr>
@@ -4018,7 +4238,7 @@
       </p:sp>
       <p:sp>
         <p:nvSpPr>
-          <p:cNvPr id="36" name="Text 36"/>
+          <p:cNvPr id="39" name="Text 39"/>
           <p:cNvSpPr txBox="1"/>
           <p:nvPr/>
         </p:nvSpPr>
@@ -4057,7 +4277,7 @@
       </p:sp>
       <p:sp>
         <p:nvSpPr>
-          <p:cNvPr id="37" name="Shape 37"/>
+          <p:cNvPr id="40" name="Shape 40"/>
           <p:cNvSpPr/>
           <p:nvPr/>
         </p:nvSpPr>
@@ -4787,7 +5007,7 @@
                 <a:ea typeface="Arial" pitchFamily="34" charset="-122"/>
                 <a:cs typeface="Arial" pitchFamily="34" charset="-120"/>
               </a:rPr>
-              <a:t>ISA SILVEIRA + LEO TORRES</a:t>
+              <a:t>ISA SILVEIRA</a:t>
             </a:r>
             <a:endParaRPr lang="pt-BR" sz="1200" dirty="0"/>
           </a:p>
@@ -4807,7 +5027,7 @@
                 <a:ea typeface="Arial" pitchFamily="34" charset="-122"/>
                 <a:cs typeface="Arial" pitchFamily="34" charset="-120"/>
               </a:rPr>
-              <a:t>Liderança de criação</a:t>
+              <a:t>Diretora de criação</a:t>
             </a:r>
             <a:endParaRPr lang="pt-BR" sz="1200" dirty="0"/>
           </a:p>
@@ -4821,7 +5041,117 @@
         </p:nvSpPr>
         <p:spPr>
           <a:xfrm>
-            <a:off x="3926840" y="3721608"/>
+            <a:off x="6096000" y="3658108"/>
+            <a:ext cx="0" cy="152400"/>
+          </a:xfrm>
+          <a:prstGeom prst="line">
+            <a:avLst/>
+          </a:prstGeom>
+          <a:noFill/>
+          <a:ln w="19050">
+            <a:solidFill>
+              <a:srgbClr val="141414"/>
+            </a:solidFill>
+            <a:prstDash val="solid"/>
+          </a:ln>
+        </p:spPr>
+      </p:sp>
+      <p:sp>
+        <p:nvSpPr>
+          <p:cNvPr id="22" name="Shape 22"/>
+          <p:cNvSpPr/>
+          <p:nvPr/>
+        </p:nvSpPr>
+        <p:spPr>
+          <a:xfrm>
+            <a:off x="3926840" y="3810508"/>
+            <a:ext cx="4338320" cy="521208"/>
+          </a:xfrm>
+          <a:prstGeom prst="rect">
+            <a:avLst/>
+          </a:prstGeom>
+          <a:solidFill>
+            <a:srgbClr val="FFFFFF"/>
+          </a:solidFill>
+          <a:ln w="19050">
+            <a:solidFill>
+              <a:srgbClr val="EC6A3B"/>
+            </a:solidFill>
+            <a:prstDash val="solid"/>
+          </a:ln>
+        </p:spPr>
+      </p:sp>
+      <p:sp>
+        <p:nvSpPr>
+          <p:cNvPr id="23" name="Text 23"/>
+          <p:cNvSpPr txBox="1"/>
+          <p:nvPr/>
+        </p:nvSpPr>
+        <p:spPr>
+          <a:xfrm>
+            <a:off x="3926840" y="3810508"/>
+            <a:ext cx="4338320" cy="521208"/>
+          </a:xfrm>
+          <a:prstGeom prst="rect">
+            <a:avLst/>
+          </a:prstGeom>
+          <a:noFill/>
+          <a:ln/>
+        </p:spPr>
+        <p:txBody>
+          <a:bodyPr wrap="square" lIns="50800" tIns="76200" rIns="101600" bIns="50800" rtlCol="0" anchor="ctr"/>
+          <a:lstStyle/>
+          <a:p>
+            <a:pPr algn="ctr" indent="0" marL="0">
+              <a:spcAft>
+                <a:spcPts val="200"/>
+              </a:spcAft>
+              <a:buNone/>
+            </a:pPr>
+            <a:r>
+              <a:rPr lang="pt-BR" sz="1200" b="1" dirty="0">
+                <a:solidFill>
+                  <a:srgbClr val="141414"/>
+                </a:solidFill>
+                <a:latin typeface="Arial" pitchFamily="34" charset="0"/>
+                <a:ea typeface="Arial" pitchFamily="34" charset="-122"/>
+                <a:cs typeface="Arial" pitchFamily="34" charset="-120"/>
+              </a:rPr>
+              <a:t>LEO TORRES</a:t>
+            </a:r>
+            <a:endParaRPr lang="pt-BR" sz="1200" dirty="0"/>
+          </a:p>
+          <a:p>
+            <a:pPr algn="ctr" indent="0" marL="0">
+              <a:spcAft>
+                <a:spcPts val="200"/>
+              </a:spcAft>
+              <a:buNone/>
+            </a:pPr>
+            <a:r>
+              <a:rPr lang="pt-BR" sz="1200" dirty="0">
+                <a:solidFill>
+                  <a:srgbClr val="5E5E5E"/>
+                </a:solidFill>
+                <a:latin typeface="Arial" pitchFamily="34" charset="0"/>
+                <a:ea typeface="Arial" pitchFamily="34" charset="-122"/>
+                <a:cs typeface="Arial" pitchFamily="34" charset="-120"/>
+              </a:rPr>
+              <a:t>Líder de criação</a:t>
+            </a:r>
+            <a:endParaRPr lang="pt-BR" sz="1200" dirty="0"/>
+          </a:p>
+        </p:txBody>
+      </p:sp>
+      <p:sp>
+        <p:nvSpPr>
+          <p:cNvPr id="24" name="Shape 24"/>
+          <p:cNvSpPr/>
+          <p:nvPr/>
+        </p:nvSpPr>
+        <p:spPr>
+          <a:xfrm>
+            <a:off x="3926840" y="4395216"/>
             <a:ext cx="2131060" cy="521208"/>
           </a:xfrm>
           <a:prstGeom prst="rect">
@@ -4840,13 +5170,13 @@
       </p:sp>
       <p:sp>
         <p:nvSpPr>
-          <p:cNvPr id="22" name="Text 22"/>
-          <p:cNvSpPr txBox="1"/>
-          <p:nvPr/>
-        </p:nvSpPr>
-        <p:spPr>
-          <a:xfrm>
-            <a:off x="3926840" y="3721608"/>
+          <p:cNvPr id="25" name="Text 25"/>
+          <p:cNvSpPr txBox="1"/>
+          <p:nvPr/>
+        </p:nvSpPr>
+        <p:spPr>
+          <a:xfrm>
+            <a:off x="3926840" y="4395216"/>
             <a:ext cx="2131060" cy="521208"/>
           </a:xfrm>
           <a:prstGeom prst="rect">
@@ -4902,13 +5232,13 @@
       </p:sp>
       <p:sp>
         <p:nvSpPr>
-          <p:cNvPr id="23" name="Shape 23"/>
-          <p:cNvSpPr/>
-          <p:nvPr/>
-        </p:nvSpPr>
-        <p:spPr>
-          <a:xfrm>
-            <a:off x="6134100" y="3721608"/>
+          <p:cNvPr id="26" name="Shape 26"/>
+          <p:cNvSpPr/>
+          <p:nvPr/>
+        </p:nvSpPr>
+        <p:spPr>
+          <a:xfrm>
+            <a:off x="6134100" y="4395216"/>
             <a:ext cx="2131060" cy="521208"/>
           </a:xfrm>
           <a:prstGeom prst="rect">
@@ -4927,13 +5257,13 @@
       </p:sp>
       <p:sp>
         <p:nvSpPr>
-          <p:cNvPr id="24" name="Text 24"/>
-          <p:cNvSpPr txBox="1"/>
-          <p:nvPr/>
-        </p:nvSpPr>
-        <p:spPr>
-          <a:xfrm>
-            <a:off x="6134100" y="3721608"/>
+          <p:cNvPr id="27" name="Text 27"/>
+          <p:cNvSpPr txBox="1"/>
+          <p:nvPr/>
+        </p:nvSpPr>
+        <p:spPr>
+          <a:xfrm>
+            <a:off x="6134100" y="4395216"/>
             <a:ext cx="2131060" cy="521208"/>
           </a:xfrm>
           <a:prstGeom prst="rect">
@@ -4989,7 +5319,7 @@
       </p:sp>
       <p:sp>
         <p:nvSpPr>
-          <p:cNvPr id="25" name="Text 25"/>
+          <p:cNvPr id="28" name="Text 28"/>
           <p:cNvSpPr txBox="1"/>
           <p:nvPr/>
         </p:nvSpPr>
@@ -5030,7 +5360,7 @@
       </p:sp>
       <p:sp>
         <p:nvSpPr>
-          <p:cNvPr id="26" name="Shape 26"/>
+          <p:cNvPr id="29" name="Shape 29"/>
           <p:cNvSpPr/>
           <p:nvPr/>
         </p:nvSpPr>
@@ -5055,7 +5385,7 @@
       </p:sp>
       <p:sp>
         <p:nvSpPr>
-          <p:cNvPr id="27" name="Text 27"/>
+          <p:cNvPr id="30" name="Text 30"/>
           <p:cNvSpPr txBox="1"/>
           <p:nvPr/>
         </p:nvSpPr>
@@ -5117,7 +5447,7 @@
       </p:sp>
       <p:sp>
         <p:nvSpPr>
-          <p:cNvPr id="28" name="Shape 28"/>
+          <p:cNvPr id="31" name="Shape 31"/>
           <p:cNvSpPr/>
           <p:nvPr/>
         </p:nvSpPr>
@@ -5142,7 +5472,7 @@
       </p:sp>
       <p:sp>
         <p:nvSpPr>
-          <p:cNvPr id="29" name="Text 29"/>
+          <p:cNvPr id="32" name="Text 32"/>
           <p:cNvSpPr txBox="1"/>
           <p:nvPr/>
         </p:nvSpPr>
@@ -5204,7 +5534,7 @@
       </p:sp>
       <p:sp>
         <p:nvSpPr>
-          <p:cNvPr id="30" name="Text 30"/>
+          <p:cNvPr id="33" name="Text 33"/>
           <p:cNvSpPr txBox="1"/>
           <p:nvPr/>
         </p:nvSpPr>
@@ -5243,7 +5573,7 @@
       </p:sp>
       <p:sp>
         <p:nvSpPr>
-          <p:cNvPr id="31" name="Shape 31"/>
+          <p:cNvPr id="34" name="Shape 34"/>
           <p:cNvSpPr/>
           <p:nvPr/>
         </p:nvSpPr>
@@ -5819,7 +6149,7 @@
                 <a:ea typeface="Arial" pitchFamily="34" charset="-122"/>
                 <a:cs typeface="Arial" pitchFamily="34" charset="-120"/>
               </a:rPr>
-              <a:t>Liderança de criação</a:t>
+              <a:t>Diretora de criação</a:t>
             </a:r>
             <a:endParaRPr lang="pt-BR" sz="1200" dirty="0"/>
           </a:p>

</xml_diff>